<commit_message>
IBM deck: fix footer overlaps
</commit_message>
<xml_diff>
--- a/apresentacoes/GraniticCloud-IBM-Parceria-EN.pptx
+++ b/apresentacoes/GraniticCloud-IBM-Parceria-EN.pptx
@@ -2487,8 +2487,8 @@
         </p:nvSpPr>
         <p:spPr>
           <a:xfrm>
-            <a:off x="502920" y="5669280"/>
-            <a:ext cx="5486400" cy="914400"/>
+            <a:off x="502920" y="5623560"/>
+            <a:ext cx="5486400" cy="822960"/>
           </a:xfrm>
           <a:prstGeom prst="rect">
             <a:avLst/>
@@ -2543,8 +2543,8 @@
         </p:nvSpPr>
         <p:spPr>
           <a:xfrm>
-            <a:off x="7571232" y="5669280"/>
-            <a:ext cx="4114800" cy="822960"/>
+            <a:off x="7571232" y="5650992"/>
+            <a:ext cx="4114800" cy="777240"/>
           </a:xfrm>
           <a:prstGeom prst="rect">
             <a:avLst/>
@@ -2553,67 +2553,49 @@
           <a:ln/>
         </p:spPr>
         <p:txBody>
-          <a:bodyPr wrap="square" lIns="0" tIns="0" rIns="0" bIns="0" rtlCol="0" anchor="ctr"/>
-          <a:lstStyle/>
-          <a:p>
-            <a:pPr algn="r" indent="0" marL="0">
-              <a:lnSpc>
-                <a:spcPts val="1400"/>
-              </a:lnSpc>
-              <a:buNone/>
-            </a:pPr>
-            <a:r>
-              <a:rPr lang="en-US" sz="900" dirty="0">
-                <a:solidFill>
-                  <a:srgbClr val="6B8BB0"/>
-                </a:solidFill>
-                <a:latin typeface="Helvetica Neue" pitchFamily="34" charset="0"/>
-                <a:ea typeface="Helvetica Neue" pitchFamily="34" charset="-122"/>
-                <a:cs typeface="Helvetica Neue" pitchFamily="34" charset="-120"/>
+          <a:bodyPr wrap="square" rtlCol="0" anchor="ctr"/>
+          <a:lstStyle/>
+          <a:p>
+            <a:pPr indent="0" marL="0">
+              <a:buNone/>
+            </a:pPr>
+            <a:r>
+              <a:rPr lang="en-US" sz="850" dirty="0">
+                <a:solidFill>
+                  <a:srgbClr val="000000"/>
+                </a:solidFill>
               </a:rPr>
               <a:t>Matheus Ximenes · Founder &amp; CEO</a:t>
             </a:r>
-            <a:endParaRPr lang="en-US" sz="900" dirty="0"/>
-          </a:p>
-          <a:p>
-            <a:pPr algn="r" indent="0" marL="0">
-              <a:lnSpc>
-                <a:spcPts val="1400"/>
-              </a:lnSpc>
-              <a:buNone/>
-            </a:pPr>
-            <a:r>
-              <a:rPr lang="en-US" sz="900" dirty="0">
-                <a:solidFill>
-                  <a:srgbClr val="6B8BB0"/>
-                </a:solidFill>
-                <a:latin typeface="Helvetica Neue" pitchFamily="34" charset="0"/>
-                <a:ea typeface="Helvetica Neue" pitchFamily="34" charset="-122"/>
-                <a:cs typeface="Helvetica Neue" pitchFamily="34" charset="-120"/>
+            <a:endParaRPr lang="en-US" sz="850" dirty="0"/>
+          </a:p>
+          <a:p>
+            <a:pPr indent="0" marL="0">
+              <a:buNone/>
+            </a:pPr>
+            <a:r>
+              <a:rPr lang="en-US" sz="850" dirty="0">
+                <a:solidFill>
+                  <a:srgbClr val="000000"/>
+                </a:solidFill>
               </a:rPr>
               <a:t>Attorney · Postgraduate Cloud Computing &amp; Data Protection</a:t>
             </a:r>
-            <a:endParaRPr lang="en-US" sz="900" dirty="0"/>
-          </a:p>
-          <a:p>
-            <a:pPr algn="r" indent="0" marL="0">
-              <a:lnSpc>
-                <a:spcPts val="1400"/>
-              </a:lnSpc>
-              <a:buNone/>
-            </a:pPr>
-            <a:r>
-              <a:rPr lang="en-US" sz="900" dirty="0">
-                <a:solidFill>
-                  <a:srgbClr val="6B8BB0"/>
-                </a:solidFill>
-                <a:latin typeface="Helvetica Neue" pitchFamily="34" charset="0"/>
-                <a:ea typeface="Helvetica Neue" pitchFamily="34" charset="-122"/>
-                <a:cs typeface="Helvetica Neue" pitchFamily="34" charset="-120"/>
+            <a:endParaRPr lang="en-US" sz="850" dirty="0"/>
+          </a:p>
+          <a:p>
+            <a:pPr indent="0" marL="0">
+              <a:buNone/>
+            </a:pPr>
+            <a:r>
+              <a:rPr lang="en-US" sz="850" dirty="0">
+                <a:solidFill>
+                  <a:srgbClr val="000000"/>
+                </a:solidFill>
               </a:rPr>
               <a:t>September 2026 · São Paulo, Brazil</a:t>
             </a:r>
-            <a:endParaRPr lang="en-US" sz="900" dirty="0"/>
+            <a:endParaRPr lang="en-US" sz="850" dirty="0"/>
           </a:p>
         </p:txBody>
       </p:sp>
@@ -5334,8 +5316,8 @@
         </p:nvSpPr>
         <p:spPr>
           <a:xfrm>
-            <a:off x="502920" y="5029200"/>
-            <a:ext cx="5303520" cy="1554480"/>
+            <a:off x="502920" y="4983480"/>
+            <a:ext cx="5303520" cy="1463040"/>
           </a:xfrm>
           <a:prstGeom prst="rect">
             <a:avLst/>
@@ -5349,13 +5331,13 @@
           <a:p>
             <a:pPr marL="127000" indent="-127000">
               <a:spcAft>
-                <a:spcPts val="600"/>
+                <a:spcPts val="500"/>
               </a:spcAft>
               <a:buSzPct val="100000"/>
               <a:buChar char="▸"/>
             </a:pPr>
             <a:r>
-              <a:rPr lang="en-US" sz="1050" dirty="0">
+              <a:rPr lang="en-US" sz="1000" dirty="0">
                 <a:solidFill>
                   <a:srgbClr val="1A2332"/>
                 </a:solidFill>
@@ -5365,18 +5347,18 @@
               </a:rPr>
               <a:t>Production validation — Granite running in regulated sectors, not just benchmarks</a:t>
             </a:r>
-            <a:endParaRPr lang="en-US" sz="1050" dirty="0"/>
+            <a:endParaRPr lang="en-US" sz="1000" dirty="0"/>
           </a:p>
           <a:p>
             <a:pPr marL="127000" indent="-127000">
               <a:spcAft>
-                <a:spcPts val="600"/>
+                <a:spcPts val="500"/>
               </a:spcAft>
               <a:buSzPct val="100000"/>
               <a:buChar char="▸"/>
             </a:pPr>
             <a:r>
-              <a:rPr lang="en-US" sz="1050" dirty="0">
+              <a:rPr lang="en-US" sz="1000" dirty="0">
                 <a:solidFill>
                   <a:srgbClr val="1A2332"/>
                 </a:solidFill>
@@ -5386,18 +5368,18 @@
               </a:rPr>
               <a:t>Market access — 1.75M regulated professionals in Brazil, 650M in LATAM</a:t>
             </a:r>
-            <a:endParaRPr lang="en-US" sz="1050" dirty="0"/>
+            <a:endParaRPr lang="en-US" sz="1000" dirty="0"/>
           </a:p>
           <a:p>
             <a:pPr marL="127000" indent="-127000">
               <a:spcAft>
-                <a:spcPts val="600"/>
+                <a:spcPts val="500"/>
               </a:spcAft>
               <a:buSzPct val="100000"/>
               <a:buChar char="▸"/>
             </a:pPr>
             <a:r>
-              <a:rPr lang="en-US" sz="1050" dirty="0">
+              <a:rPr lang="en-US" sz="1000" dirty="0">
                 <a:solidFill>
                   <a:srgbClr val="1A2332"/>
                 </a:solidFill>
@@ -5407,18 +5389,18 @@
               </a:rPr>
               <a:t>granitic.cloud — premium domain for the joint product</a:t>
             </a:r>
-            <a:endParaRPr lang="en-US" sz="1050" dirty="0"/>
+            <a:endParaRPr lang="en-US" sz="1000" dirty="0"/>
           </a:p>
           <a:p>
             <a:pPr marL="127000" indent="-127000">
               <a:spcAft>
-                <a:spcPts val="600"/>
+                <a:spcPts val="500"/>
               </a:spcAft>
               <a:buSzPct val="100000"/>
               <a:buChar char="▸"/>
             </a:pPr>
             <a:r>
-              <a:rPr lang="en-US" sz="1050" dirty="0">
+              <a:rPr lang="en-US" sz="1000" dirty="0">
                 <a:solidFill>
                   <a:srgbClr val="1A2332"/>
                 </a:solidFill>
@@ -5428,7 +5410,7 @@
               </a:rPr>
               <a:t>watsonx integration — sovereign deployment in territory IBM cannot reach alone</a:t>
             </a:r>
-            <a:endParaRPr lang="en-US" sz="1050" dirty="0"/>
+            <a:endParaRPr lang="en-US" sz="1000" dirty="0"/>
           </a:p>
         </p:txBody>
       </p:sp>
@@ -5479,8 +5461,8 @@
         </p:nvSpPr>
         <p:spPr>
           <a:xfrm>
-            <a:off x="6400800" y="5029200"/>
-            <a:ext cx="5303520" cy="1554480"/>
+            <a:off x="6400800" y="4983480"/>
+            <a:ext cx="5303520" cy="1463040"/>
           </a:xfrm>
           <a:prstGeom prst="rect">
             <a:avLst/>
@@ -5494,13 +5476,13 @@
           <a:p>
             <a:pPr marL="127000" indent="-127000">
               <a:spcAft>
-                <a:spcPts val="600"/>
+                <a:spcPts val="500"/>
               </a:spcAft>
               <a:buSzPct val="100000"/>
               <a:buChar char="▸"/>
             </a:pPr>
             <a:r>
-              <a:rPr lang="en-US" sz="1050" dirty="0">
+              <a:rPr lang="en-US" sz="1000" dirty="0">
                 <a:solidFill>
                   <a:srgbClr val="1A2332"/>
                 </a:solidFill>
@@ -5510,18 +5492,18 @@
               </a:rPr>
               <a:t>Granite in production — guardrail on every response, compliance in every vertical</a:t>
             </a:r>
-            <a:endParaRPr lang="en-US" sz="1050" dirty="0"/>
+            <a:endParaRPr lang="en-US" sz="1000" dirty="0"/>
           </a:p>
           <a:p>
             <a:pPr marL="127000" indent="-127000">
               <a:spcAft>
-                <a:spcPts val="600"/>
+                <a:spcPts val="500"/>
               </a:spcAft>
               <a:buSzPct val="100000"/>
               <a:buChar char="▸"/>
             </a:pPr>
             <a:r>
-              <a:rPr lang="en-US" sz="1050" dirty="0">
+              <a:rPr lang="en-US" sz="1000" dirty="0">
                 <a:solidFill>
                   <a:srgbClr val="1A2332"/>
                 </a:solidFill>
@@ -5531,18 +5513,18 @@
               </a:rPr>
               <a:t>4 regulated verticals live — Legal (77M+ decisions), Compliance, Health, Real Estate</a:t>
             </a:r>
-            <a:endParaRPr lang="en-US" sz="1050" dirty="0"/>
+            <a:endParaRPr lang="en-US" sz="1000" dirty="0"/>
           </a:p>
           <a:p>
             <a:pPr marL="127000" indent="-127000">
               <a:spcAft>
-                <a:spcPts val="600"/>
+                <a:spcPts val="500"/>
               </a:spcAft>
               <a:buSzPct val="100000"/>
               <a:buChar char="▸"/>
             </a:pPr>
             <a:r>
-              <a:rPr lang="en-US" sz="1050" dirty="0">
+              <a:rPr lang="en-US" sz="1000" dirty="0">
                 <a:solidFill>
                   <a:srgbClr val="1A2332"/>
                 </a:solidFill>
@@ -5552,18 +5534,18 @@
               </a:rPr>
               <a:t>Sovereign data centers — PB (solar off-grid) + CE (ZPE, subsea)</a:t>
             </a:r>
-            <a:endParaRPr lang="en-US" sz="1050" dirty="0"/>
+            <a:endParaRPr lang="en-US" sz="1000" dirty="0"/>
           </a:p>
           <a:p>
             <a:pPr marL="127000" indent="-127000">
               <a:spcAft>
-                <a:spcPts val="600"/>
+                <a:spcPts val="500"/>
               </a:spcAft>
               <a:buSzPct val="100000"/>
               <a:buChar char="▸"/>
             </a:pPr>
             <a:r>
-              <a:rPr lang="en-US" sz="1050" dirty="0">
+              <a:rPr lang="en-US" sz="1000" dirty="0">
                 <a:solidFill>
                   <a:srgbClr val="1A2332"/>
                 </a:solidFill>
@@ -5573,7 +5555,7 @@
               </a:rPr>
               <a:t>Regulatory expertise — founder attorney, 12 years Judiciary</a:t>
             </a:r>
-            <a:endParaRPr lang="en-US" sz="1050" dirty="0"/>
+            <a:endParaRPr lang="en-US" sz="1000" dirty="0"/>
           </a:p>
         </p:txBody>
       </p:sp>

</xml_diff>